<commit_message>
Refine PPT decks with HTML visuals
</commit_message>
<xml_diff>
--- a/materials/presentations/guia-hub-investimentos-internacionais-apresentacao.pptx
+++ b/materials/presentations/guia-hub-investimentos-internacionais-apresentacao.pptx
@@ -1768,7 +1768,7 @@
                 <a:ea typeface="Segoe UI" pitchFamily="34" charset="-122"/>
                 <a:cs typeface="Segoe UI" pitchFamily="34" charset="-120"/>
               </a:rPr>
-              <a:t>Apresentacao em PowerPoint baseada no HTML operacional para transformar a navegacao do HUB, o fluxo de cambio e o uso da conta global em um roteiro visual e editavel.</a:t>
+              <a:t>Apresentacao em PowerPoint para transformar a navegacao do HUB, o fluxo de cambio e o uso da conta global em um roteiro visual e editavel.</a:t>
             </a:r>
             <a:endParaRPr lang="en-US" sz="1495" dirty="0"/>
           </a:p>
@@ -2322,7 +2322,7 @@
                 <a:ea typeface="Segoe UI" pitchFamily="34" charset="-122"/>
                 <a:cs typeface="Segoe UI" pitchFamily="34" charset="-120"/>
               </a:rPr>
-              <a:t>Baseado no conteudo do HTML publicado no projeto.</a:t>
+              <a:t>Alta Vista Investimentos | Material de apoio</a:t>
             </a:r>
             <a:endParaRPr lang="en-US" sz="900" dirty="0"/>
           </a:p>
@@ -2673,7 +2673,7 @@
                 <a:ea typeface="Segoe UI" pitchFamily="34" charset="-122"/>
                 <a:cs typeface="Segoe UI" pitchFamily="34" charset="-120"/>
               </a:rPr>
-              <a:t>O material operacional organiza a jornada internacional do assessor como um fluxo continuo: entrar no ambiente certo, ler a situacao do cliente, transformar saldo local em funding internacional e acompanhar a alocacao ate a conclusao.</a:t>
+              <a:t>A jornada internacional do assessor pode ser organizada como um fluxo continuo: entrar no ambiente certo, ler a situacao do cliente, transformar saldo local em funding internacional e acompanhar a alocacao ate a conclusao.</a:t>
             </a:r>
             <a:endParaRPr lang="en-US" sz="1255" dirty="0"/>
           </a:p>
@@ -4250,7 +4250,7 @@
                 <a:ea typeface="Segoe UI" pitchFamily="34" charset="-122"/>
                 <a:cs typeface="Segoe UI" pitchFamily="34" charset="-120"/>
               </a:rPr>
-              <a:t>O HTML deixa claro que a orientacao inicial do assessor depende de duas leituras simultaneas: o caminho lateral para entrar no modulo correto e a regua superior para mudar de assunto sem perder o cliente de vista.</a:t>
+              <a:t>A orientacao inicial do assessor depende de duas leituras simultaneas: o caminho lateral para entrar no modulo correto e a regua superior para mudar de assunto sem perder o cliente de vista.</a:t>
             </a:r>
             <a:endParaRPr lang="en-US" sz="1255" dirty="0"/>
           </a:p>
@@ -5263,7 +5263,7 @@
                 <a:ea typeface="Segoe UI" pitchFamily="34" charset="-122"/>
                 <a:cs typeface="Segoe UI" pitchFamily="34" charset="-120"/>
               </a:rPr>
-              <a:t>No fluxo do HTML, a consulta do cliente e o centro de gravidade da operacao: e ali que o assessor identifica se a conta existe, se o onboarding terminou e qual e a situacao patrimonial antes de falar de cambio ou produto.</a:t>
+              <a:t>Na operacao, a consulta do cliente e o centro de gravidade: e ali que o assessor identifica se a conta existe, se o onboarding terminou e qual e a situacao patrimonial antes de falar de cambio ou produto.</a:t>
             </a:r>
             <a:endParaRPr lang="en-US" sz="1255" dirty="0"/>
           </a:p>
@@ -6607,7 +6607,7 @@
                 <a:ea typeface="Segoe UI" pitchFamily="34" charset="-122"/>
                 <a:cs typeface="Segoe UI" pitchFamily="34" charset="-120"/>
               </a:rPr>
-              <a:t>O HTML transforma o cadastro de beneficiarios em um passo a passo objetivo. Depois de validar a conta global no HUB, o cliente pode concluir essa frente pelo proprio app da XP.</a:t>
+              <a:t>O cadastro de beneficiarios pode ser apresentado como um passo a passo objetivo. Depois de validar a conta global no HUB, o cliente pode concluir essa frente pelo proprio app da XP.</a:t>
             </a:r>
             <a:endParaRPr lang="en-US" sz="1255" dirty="0"/>
           </a:p>
@@ -7849,7 +7849,7 @@
                 <a:ea typeface="Segoe UI" pitchFamily="34" charset="-122"/>
                 <a:cs typeface="Segoe UI" pitchFamily="34" charset="-120"/>
               </a:rPr>
-              <a:t>No HTML, o cambio e a ponte entre o saldo em reais e o funding da conta internacional. O processo e simples, mas depende de conferencia operacional disciplinada antes do envio.</a:t>
+              <a:t>O cambio e a ponte entre o saldo em reais e o funding da conta internacional. O processo e simples, mas depende de conferencia operacional disciplinada antes do envio.</a:t>
             </a:r>
             <a:endParaRPr lang="en-US" sz="1255" dirty="0"/>
           </a:p>
@@ -9091,7 +9091,7 @@
                 <a:ea typeface="Segoe UI" pitchFamily="34" charset="-122"/>
                 <a:cs typeface="Segoe UI" pitchFamily="34" charset="-120"/>
               </a:rPr>
-              <a:t>A prateleira de produtos do HTML mostra que o processo nao termina no cambio. O assessor precisa converter a conta abastecida em uma proposta concreta de alocacao e envio ao cliente.</a:t>
+              <a:t>A prateleira de produtos mostra que o processo nao termina no cambio. O assessor precisa converter a conta abastecida em uma proposta concreta de alocacao e envio ao cliente.</a:t>
             </a:r>
             <a:endParaRPr lang="en-US" sz="1255" dirty="0"/>
           </a:p>
@@ -10007,7 +10007,7 @@
                 <a:ea typeface="Segoe UI" pitchFamily="34" charset="-122"/>
                 <a:cs typeface="Segoe UI" pitchFamily="34" charset="-120"/>
               </a:rPr>
-              <a:t>O encerramento do HTML mostra que a visibilidade pos-operacao e parte da propria experiencia do assessor. O controle do status evita perder timing e reduz a necessidade de consultas dispersas.</a:t>
+              <a:t>A visibilidade pos-operacao e parte da propria experiencia do assessor. O controle do status evita perder timing e reduz a necessidade de consultas dispersas.</a:t>
             </a:r>
             <a:endParaRPr lang="en-US" sz="1255" dirty="0"/>
           </a:p>

</xml_diff>